<commit_message>
docs: synchronize current evidence and deliverables
</commit_message>
<xml_diff>
--- a/deliverables/ppt/OS_Agent_记忆优化_答辩稿.pptx
+++ b/deliverables/ppt/OS_Agent_记忆优化_答辩稿.pptx
@@ -5233,7 +5233,7 @@
                 </a:solidFill>
                 <a:latin typeface="Microsoft YaHei"/>
               </a:rPr>
-              <a:t>54 项通过</a:t>
+              <a:t>61 项通过</a:t>
             </a:r>
           </a:p>
         </p:txBody>
@@ -6785,7 +6785,7 @@
                 </a:solidFill>
                 <a:latin typeface="Microsoft YaHei"/>
               </a:rPr>
-              <a:t>test 指标、54 测试、10k 性能</a:t>
+              <a:t>test 指标、61 测试、10k 性能</a:t>
             </a:r>
           </a:p>
         </p:txBody>
@@ -8137,7 +8137,7 @@
                 </a:solidFill>
                 <a:latin typeface="Microsoft YaHei"/>
               </a:rPr>
-              <a:t>词法候选 + 向量缓存；10k 开发机 p99 73.445ms</a:t>
+              <a:t>词法候选 + 向量缓存；10k 开发机 p99 57.641ms</a:t>
             </a:r>
           </a:p>
         </p:txBody>
@@ -13726,7 +13726,7 @@
                 </a:solidFill>
                 <a:latin typeface="Microsoft YaHei"/>
               </a:rPr>
-              <a:t>62.541 ms</a:t>
+              <a:t>45.801 ms</a:t>
             </a:r>
           </a:p>
         </p:txBody>
@@ -13885,7 +13885,7 @@
                 </a:solidFill>
                 <a:latin typeface="Microsoft YaHei"/>
               </a:rPr>
-              <a:t>73.445 ms</a:t>
+              <a:t>57.641 ms</a:t>
             </a:r>
           </a:p>
         </p:txBody>

</xml_diff>

<commit_message>
feat: verify and archive self-contained submission draft
</commit_message>
<xml_diff>
--- a/deliverables/ppt/OS_Agent_记忆优化_答辩稿.pptx
+++ b/deliverables/ppt/OS_Agent_记忆优化_答辩稿.pptx
@@ -5233,7 +5233,7 @@
                 </a:solidFill>
                 <a:latin typeface="Microsoft YaHei"/>
               </a:rPr>
-              <a:t>61 项通过</a:t>
+              <a:t>65 项通过</a:t>
             </a:r>
           </a:p>
         </p:txBody>
@@ -6785,7 +6785,7 @@
                 </a:solidFill>
                 <a:latin typeface="Microsoft YaHei"/>
               </a:rPr>
-              <a:t>test 指标、61 测试、10k 性能</a:t>
+              <a:t>test 指标、65 测试、10k 性能</a:t>
             </a:r>
           </a:p>
         </p:txBody>
@@ -8137,7 +8137,7 @@
                 </a:solidFill>
                 <a:latin typeface="Microsoft YaHei"/>
               </a:rPr>
-              <a:t>词法候选 + 向量缓存；10k 开发机 p99 57.641ms</a:t>
+              <a:t>词法候选 + 向量缓存；10k 开发机 p99 112.732ms</a:t>
             </a:r>
           </a:p>
         </p:txBody>
@@ -13726,7 +13726,7 @@
                 </a:solidFill>
                 <a:latin typeface="Microsoft YaHei"/>
               </a:rPr>
-              <a:t>45.801 ms</a:t>
+              <a:t>87.62 ms</a:t>
             </a:r>
           </a:p>
         </p:txBody>
@@ -13885,7 +13885,7 @@
                 </a:solidFill>
                 <a:latin typeface="Microsoft YaHei"/>
               </a:rPr>
-              <a:t>57.641 ms</a:t>
+              <a:t>112.732 ms</a:t>
             </a:r>
           </a:p>
         </p:txBody>

</xml_diff>

<commit_message>
build: verify and package evidence-driven round-two release (R14)
</commit_message>
<xml_diff>
--- a/deliverables/ppt/OS_Agent_记忆优化_答辩稿.pptx
+++ b/deliverables/ppt/OS_Agent_记忆优化_答辩稿.pptx
@@ -3397,7 +3397,7 @@
                 </a:solidFill>
                 <a:latin typeface="Microsoft YaHei"/>
               </a:rPr>
-              <a:t>答辩稿 v1.0  ·  2026-09-05</a:t>
+              <a:t>第二轮开发机答辩稿 · 2026-09-06</a:t>
             </a:r>
           </a:p>
         </p:txBody>
@@ -4234,7 +4234,7 @@
                 </a:solidFill>
                 <a:latin typeface="Microsoft YaHei"/>
               </a:rPr>
-              <a:t>偏好 F1</a:t>
+              <a:t>正例 Recall@3</a:t>
             </a:r>
           </a:p>
         </p:txBody>
@@ -4269,7 +4269,7 @@
                 </a:solidFill>
                 <a:latin typeface="Microsoft YaHei"/>
               </a:rPr>
-              <a:t>1.0000</a:t>
+              <a:t>0.8333</a:t>
             </a:r>
           </a:p>
         </p:txBody>
@@ -4304,7 +4304,7 @@
                 </a:solidFill>
                 <a:latin typeface="Microsoft YaHei"/>
               </a:rPr>
-              <a:t>test 分区</a:t>
+              <a:t>v3 test · 12 正例</a:t>
             </a:r>
           </a:p>
         </p:txBody>
@@ -4393,7 +4393,7 @@
                 </a:solidFill>
                 <a:latin typeface="Microsoft YaHei"/>
               </a:rPr>
-              <a:t>检索 P@3 / R@3</a:t>
+              <a:t>无答案正确率</a:t>
             </a:r>
           </a:p>
         </p:txBody>
@@ -4428,7 +4428,7 @@
                 </a:solidFill>
                 <a:latin typeface="Microsoft YaHei"/>
               </a:rPr>
-              <a:t>0.9286 / 1.0</a:t>
+              <a:t>0.8333</a:t>
             </a:r>
           </a:p>
         </p:txBody>
@@ -4463,7 +4463,7 @@
                 </a:solidFill>
                 <a:latin typeface="Microsoft YaHei"/>
               </a:rPr>
-              <a:t>含空答案</a:t>
+              <a:t>v3 test · 6 无答案</a:t>
             </a:r>
           </a:p>
         </p:txBody>
@@ -4552,7 +4552,7 @@
                 </a:solidFill>
                 <a:latin typeface="Microsoft YaHei"/>
               </a:rPr>
-              <a:t>MRR / nDCG@3</a:t>
+              <a:t>平衡得分</a:t>
             </a:r>
           </a:p>
         </p:txBody>
@@ -4587,7 +4587,7 @@
                 </a:solidFill>
                 <a:latin typeface="Microsoft YaHei"/>
               </a:rPr>
-              <a:t>1.0 / 1.0</a:t>
+              <a:t>0.8333</a:t>
             </a:r>
           </a:p>
         </p:txBody>
@@ -4622,7 +4622,7 @@
                 </a:solidFill>
                 <a:latin typeface="Microsoft YaHei"/>
               </a:rPr>
-              <a:t>排序质量</a:t>
+              <a:t>召回与拒答平均</a:t>
             </a:r>
           </a:p>
         </p:txBody>
@@ -4711,7 +4711,7 @@
                 </a:solidFill>
                 <a:latin typeface="Microsoft YaHei"/>
               </a:rPr>
-              <a:t>遗忘 F1 / 误删</a:t>
+              <a:t>质量目标</a:t>
             </a:r>
           </a:p>
         </p:txBody>
@@ -4746,7 +4746,7 @@
                 </a:solidFill>
                 <a:latin typeface="Microsoft YaHei"/>
               </a:rPr>
-              <a:t>1.0 / 0</a:t>
+              <a:t>尚未全满足</a:t>
             </a:r>
           </a:p>
         </p:txBody>
@@ -4781,7 +4781,7 @@
                 </a:solidFill>
                 <a:latin typeface="Microsoft YaHei"/>
               </a:rPr>
-              <a:t>完整授权集</a:t>
+              <a:t>两项分别 ≥ 0.85</a:t>
             </a:r>
           </a:p>
         </p:txBody>
@@ -4816,7 +4816,7 @@
                 </a:solidFill>
                 <a:latin typeface="Microsoft YaHei"/>
               </a:rPr>
-              <a:t>120 条可重复生成的合成事件</a:t>
+              <a:t>42 事件 · 18 主题 · 54 查询</a:t>
             </a:r>
           </a:p>
         </p:txBody>
@@ -4855,7 +4855,7 @@
               </a:defRPr>
             </a:pPr>
             <a:r>
-              <a:t>•  train / dev / test 各 40 条</a:t>
+              <a:t>•  正文/模板族跨分区交集为零</a:t>
             </a:r>
           </a:p>
           <a:p>
@@ -4871,7 +4871,7 @@
               </a:defRPr>
             </a:pPr>
             <a:r>
-              <a:t>•  6 类核心办公/系统场景 + 噪声</a:t>
+              <a:t>•  统一阈值 0.24 仅由 dev 选择</a:t>
             </a:r>
           </a:p>
           <a:p>
@@ -4887,7 +4887,7 @@
               </a:defRPr>
             </a:pPr>
             <a:r>
-              <a:t>•  失败工具、注入、冲突、隐私、跨用户反例</a:t>
+              <a:t>•  词法/向量/混合对照：不宣称全面领先</a:t>
             </a:r>
           </a:p>
         </p:txBody>
@@ -5233,7 +5233,7 @@
                 </a:solidFill>
                 <a:latin typeface="Microsoft YaHei"/>
               </a:rPr>
-              <a:t>65 项通过</a:t>
+              <a:t>86 项通过</a:t>
             </a:r>
           </a:p>
         </p:txBody>
@@ -6785,7 +6785,7 @@
                 </a:solidFill>
                 <a:latin typeface="Microsoft YaHei"/>
               </a:rPr>
-              <a:t>test 指标、65 测试、10k 性能</a:t>
+              <a:t>v3 对照、86 测试、10k 性能</a:t>
             </a:r>
           </a:p>
         </p:txBody>
@@ -7094,7 +7094,7 @@
                 </a:solidFill>
                 <a:latin typeface="Microsoft YaHei"/>
               </a:rPr>
-              <a:t>✓  核心原型</a:t>
+              <a:t>✓  统一生命周期门控</a:t>
             </a:r>
           </a:p>
         </p:txBody>
@@ -7148,7 +7148,7 @@
                 </a:solidFill>
                 <a:latin typeface="Microsoft YaHei"/>
               </a:rPr>
-              <a:t>✓  SQLite v2</a:t>
+              <a:t>✓  增量事务与失败回滚</a:t>
             </a:r>
           </a:p>
         </p:txBody>
@@ -7202,7 +7202,7 @@
                 </a:solidFill>
                 <a:latin typeface="Microsoft YaHei"/>
               </a:rPr>
-              <a:t>✓  服务/API/Web</a:t>
+              <a:t>✓  服务/API/场景演示</a:t>
             </a:r>
           </a:p>
         </p:txBody>
@@ -7256,7 +7256,7 @@
                 </a:solidFill>
                 <a:latin typeface="Microsoft YaHei"/>
               </a:rPr>
-              <a:t>✓  120 条分区集</a:t>
+              <a:t>✓  v3 隔离分区与对照</a:t>
             </a:r>
           </a:p>
         </p:txBody>
@@ -7310,7 +7310,7 @@
                 </a:solidFill>
                 <a:latin typeface="Microsoft YaHei"/>
               </a:rPr>
-              <a:t>✓  10k 开发机基准</a:t>
+              <a:t>✓  10k 检索 + 实际服务负载</a:t>
             </a:r>
           </a:p>
         </p:txBody>
@@ -7364,7 +7364,7 @@
                 </a:solidFill>
                 <a:latin typeface="Microsoft YaHei"/>
               </a:rPr>
-              <a:t>✓  安全测试</a:t>
+              <a:t>✓  作用域与重启安全测试</a:t>
             </a:r>
           </a:p>
         </p:txBody>
@@ -8137,7 +8137,7 @@
                 </a:solidFill>
                 <a:latin typeface="Microsoft YaHei"/>
               </a:rPr>
-              <a:t>词法候选 + 向量缓存；10k 开发机 p99 112.732ms</a:t>
+              <a:t>候选合并 + 向量缓存；10k 开发机 p99 129.045ms</a:t>
             </a:r>
           </a:p>
         </p:txBody>
@@ -13726,7 +13726,7 @@
                 </a:solidFill>
                 <a:latin typeface="Microsoft YaHei"/>
               </a:rPr>
-              <a:t>87.62 ms</a:t>
+              <a:t>96.972 ms</a:t>
             </a:r>
           </a:p>
         </p:txBody>
@@ -13885,7 +13885,7 @@
                 </a:solidFill>
                 <a:latin typeface="Microsoft YaHei"/>
               </a:rPr>
-              <a:t>112.732 ms</a:t>
+              <a:t>129.045 ms</a:t>
             </a:r>
           </a:p>
         </p:txBody>
@@ -14044,7 +14044,7 @@
                 </a:solidFill>
                 <a:latin typeface="Microsoft YaHei"/>
               </a:rPr>
-              <a:t>39.977 MB</a:t>
+              <a:t>39.984 MB</a:t>
             </a:r>
           </a:p>
         </p:txBody>

</xml_diff>

<commit_message>
docs: synchronize third round metrics and disclose quality latency tradeoff
</commit_message>
<xml_diff>
--- a/deliverables/ppt/OS_Agent_记忆优化_答辩稿.pptx
+++ b/deliverables/ppt/OS_Agent_记忆优化_答辩稿.pptx
@@ -3397,7 +3397,7 @@
                 </a:solidFill>
                 <a:latin typeface="Microsoft YaHei"/>
               </a:rPr>
-              <a:t>第二轮开发机答辩稿 · 2026-09-06</a:t>
+              <a:t>第三轮开发机答辩稿 · 2026-09-06</a:t>
             </a:r>
           </a:p>
         </p:txBody>
@@ -4269,7 +4269,7 @@
                 </a:solidFill>
                 <a:latin typeface="Microsoft YaHei"/>
               </a:rPr>
-              <a:t>0.8333</a:t>
+              <a:t>0.9167</a:t>
             </a:r>
           </a:p>
         </p:txBody>
@@ -4428,7 +4428,7 @@
                 </a:solidFill>
                 <a:latin typeface="Microsoft YaHei"/>
               </a:rPr>
-              <a:t>0.8333</a:t>
+              <a:t>1.0000</a:t>
             </a:r>
           </a:p>
         </p:txBody>
@@ -4587,7 +4587,7 @@
                 </a:solidFill>
                 <a:latin typeface="Microsoft YaHei"/>
               </a:rPr>
-              <a:t>0.8333</a:t>
+              <a:t>0.9583</a:t>
             </a:r>
           </a:p>
         </p:txBody>
@@ -4646,7 +4646,7 @@
           </a:solidFill>
           <a:ln w="15240">
             <a:solidFill>
-              <a:srgbClr val="FFC15C"/>
+              <a:srgbClr val="45DEC4"/>
             </a:solidFill>
           </a:ln>
         </p:spPr>
@@ -4711,7 +4711,7 @@
                 </a:solidFill>
                 <a:latin typeface="Microsoft YaHei"/>
               </a:rPr>
-              <a:t>质量目标</a:t>
+              <a:t>内部质量目标</a:t>
             </a:r>
           </a:p>
         </p:txBody>
@@ -4742,11 +4742,11 @@
             <a:r>
               <a:rPr sz="2500" b="1">
                 <a:solidFill>
-                  <a:srgbClr val="FFC15C"/>
-                </a:solidFill>
-                <a:latin typeface="Microsoft YaHei"/>
-              </a:rPr>
-              <a:t>尚未全满足</a:t>
+                  <a:srgbClr val="45DEC4"/>
+                </a:solidFill>
+                <a:latin typeface="Microsoft YaHei"/>
+              </a:rPr>
+              <a:t>两项已满足</a:t>
             </a:r>
           </a:p>
         </p:txBody>
@@ -4871,7 +4871,7 @@
               </a:defRPr>
             </a:pPr>
             <a:r>
-              <a:t>•  统一阈值 0.24 仅由 dev 选择</a:t>
+              <a:t>•  统一阈值 0.265 仅由 dev 选择</a:t>
             </a:r>
           </a:p>
           <a:p>
@@ -5233,7 +5233,7 @@
                 </a:solidFill>
                 <a:latin typeface="Microsoft YaHei"/>
               </a:rPr>
-              <a:t>86 项通过</a:t>
+              <a:t>91 项通过</a:t>
             </a:r>
           </a:p>
         </p:txBody>
@@ -6785,7 +6785,7 @@
                 </a:solidFill>
                 <a:latin typeface="Microsoft YaHei"/>
               </a:rPr>
-              <a:t>v3 对照、86 测试、10k 性能</a:t>
+              <a:t>v3 对照、91 测试、10k 性能</a:t>
             </a:r>
           </a:p>
         </p:txBody>
@@ -8137,7 +8137,7 @@
                 </a:solidFill>
                 <a:latin typeface="Microsoft YaHei"/>
               </a:rPr>
-              <a:t>候选合并 + 向量缓存；10k 开发机 p99 129.045ms</a:t>
+              <a:t>候选合并 + 向量缓存；10k 开发机 p99 362.265ms</a:t>
             </a:r>
           </a:p>
         </p:txBody>
@@ -13281,7 +13281,7 @@
                 </a:solidFill>
                 <a:latin typeface="Microsoft YaHei"/>
               </a:rPr>
-              <a:t>词法候选</a:t>
+              <a:t>多路候选</a:t>
             </a:r>
           </a:p>
         </p:txBody>
@@ -13459,7 +13459,7 @@
                 </a:solidFill>
                 <a:latin typeface="Microsoft YaHei"/>
               </a:rPr>
-              <a:t>语义重排</a:t>
+              <a:t>多粒度重排</a:t>
             </a:r>
           </a:p>
         </p:txBody>
@@ -13596,13 +13596,13 @@
           <a:p>
             <a:pPr algn="ctr"/>
             <a:r>
-              <a:rPr sz="2100" b="1">
+              <a:rPr sz="2000" b="1">
                 <a:solidFill>
                   <a:srgbClr val="EEF6FF"/>
                 </a:solidFill>
                 <a:latin typeface="Microsoft YaHei"/>
               </a:rPr>
-              <a:t>score = 0.65 × semantic + 0.30 × lexical + 0.05 × authority</a:t>
+              <a:t>中文：0.25 向量 + 0.25 词法 + 0.45 汉字覆盖 + 0.05 权威度</a:t>
             </a:r>
           </a:p>
         </p:txBody>
@@ -13726,7 +13726,7 @@
                 </a:solidFill>
                 <a:latin typeface="Microsoft YaHei"/>
               </a:rPr>
-              <a:t>96.972 ms</a:t>
+              <a:t>246.796 ms</a:t>
             </a:r>
           </a:p>
         </p:txBody>
@@ -13885,7 +13885,7 @@
                 </a:solidFill>
                 <a:latin typeface="Microsoft YaHei"/>
               </a:rPr>
-              <a:t>129.045 ms</a:t>
+              <a:t>362.265 ms</a:t>
             </a:r>
           </a:p>
         </p:txBody>

</xml_diff>

<commit_message>
chore(resume): preserve interrupted round4 work and acceptance todo
</commit_message>
<xml_diff>
--- a/deliverables/ppt/OS_Agent_记忆优化_答辩稿.pptx
+++ b/deliverables/ppt/OS_Agent_记忆优化_答辩稿.pptx
@@ -3362,7 +3362,7 @@
                 </a:solidFill>
                 <a:latin typeface="Microsoft YaHei"/>
               </a:rPr>
-              <a:t>真实麒麟 + SDK 待验收</a:t>
+              <a:t>V11 实测与 SDK 分开验收</a:t>
             </a:r>
           </a:p>
         </p:txBody>
@@ -3397,7 +3397,7 @@
                 </a:solidFill>
                 <a:latin typeface="Microsoft YaHei"/>
               </a:rPr>
-              <a:t>第三轮开发机答辩稿 · 2026-09-06</a:t>
+              <a:t>第四轮官方口径整改稿 · 2026-09-07</a:t>
             </a:r>
           </a:p>
         </p:txBody>
@@ -4075,7 +4075,7 @@
                 </a:solidFill>
                 <a:latin typeface="Microsoft YaHei"/>
               </a:rPr>
-              <a:t>10  评测体系：开始惩罚“多报、误删、乱答”</a:t>
+              <a:t>10  官方五项指标：当前内部证据与缺口</a:t>
             </a:r>
           </a:p>
         </p:txBody>
@@ -4158,8 +4158,8 @@
         </p:nvSpPr>
         <p:spPr>
           <a:xfrm>
-            <a:off x="594360" y="1143000"/>
-            <a:ext cx="2606040" cy="1234440"/>
+            <a:off x="685800" y="1078992"/>
+            <a:ext cx="3383280" cy="576072"/>
           </a:xfrm>
           <a:prstGeom prst="roundRect">
             <a:avLst/>
@@ -4169,7 +4169,7 @@
           </a:solidFill>
           <a:ln w="15240">
             <a:solidFill>
-              <a:srgbClr val="45DEC4"/>
+              <a:srgbClr val="183048"/>
             </a:solidFill>
           </a:ln>
         </p:spPr>
@@ -4193,13 +4193,13 @@
           <a:p>
             <a:pPr algn="ctr"/>
             <a:r>
-              <a:rPr sz="1700" b="1">
+              <a:rPr sz="1600" b="1">
                 <a:solidFill>
                   <a:srgbClr val="EEF6FF"/>
                 </a:solidFill>
                 <a:latin typeface="Microsoft YaHei"/>
               </a:rPr>
-              <a:t/>
+              <a:t>偏好准确率 ≥85%</a:t>
             </a:r>
           </a:p>
         </p:txBody>
@@ -4212,8 +4212,8 @@
         </p:nvSpPr>
         <p:spPr>
           <a:xfrm>
-            <a:off x="758952" y="1252728"/>
-            <a:ext cx="2276856" cy="274320"/>
+            <a:off x="4297680" y="1078992"/>
+            <a:ext cx="1874519" cy="576072"/>
           </a:xfrm>
           <a:prstGeom prst="rect">
             <a:avLst/>
@@ -4228,13 +4228,13 @@
           <a:p>
             <a:pPr algn="l"/>
             <a:r>
-              <a:rPr sz="1100" b="0">
-                <a:solidFill>
-                  <a:srgbClr val="A3BBD2"/>
-                </a:solidFill>
-                <a:latin typeface="Microsoft YaHei"/>
-              </a:rPr>
-              <a:t>正例 Recall@3</a:t>
+              <a:rPr sz="2200" b="1">
+                <a:solidFill>
+                  <a:srgbClr val="FFC15C"/>
+                </a:solidFill>
+                <a:latin typeface="Microsoft YaHei"/>
+              </a:rPr>
+              <a:t>46.15%</a:t>
             </a:r>
           </a:p>
         </p:txBody>
@@ -4247,8 +4247,8 @@
         </p:nvSpPr>
         <p:spPr>
           <a:xfrm>
-            <a:off x="758952" y="1527048"/>
-            <a:ext cx="2276856" cy="438912"/>
+            <a:off x="6400800" y="1078992"/>
+            <a:ext cx="4846320" cy="576072"/>
           </a:xfrm>
           <a:prstGeom prst="rect">
             <a:avLst/>
@@ -4263,62 +4263,27 @@
           <a:p>
             <a:pPr algn="l"/>
             <a:r>
-              <a:rPr sz="2500" b="1">
-                <a:solidFill>
-                  <a:srgbClr val="45DEC4"/>
-                </a:solidFill>
-                <a:latin typeface="Microsoft YaHei"/>
-              </a:rPr>
-              <a:t>0.9167</a:t>
-            </a:r>
-          </a:p>
-        </p:txBody>
-      </p:sp>
-      <p:sp>
-        <p:nvSpPr>
-          <p:cNvPr id="8" name="TextBox 7"/>
-          <p:cNvSpPr txBox="1"/>
-          <p:nvPr/>
-        </p:nvSpPr>
-        <p:spPr>
-          <a:xfrm>
-            <a:off x="758952" y="2011680"/>
-            <a:ext cx="2276856" cy="228600"/>
-          </a:xfrm>
-          <a:prstGeom prst="rect">
-            <a:avLst/>
-          </a:prstGeom>
-          <a:noFill/>
-        </p:spPr>
-        <p:txBody>
-          <a:bodyPr wrap="square" anchor="ctr">
-            <a:spAutoFit/>
-          </a:bodyPr>
-          <a:lstStyle/>
-          <a:p>
-            <a:pPr algn="l"/>
-            <a:r>
-              <a:rPr sz="900" b="0">
+              <a:rPr sz="1500" b="0">
                 <a:solidFill>
                   <a:srgbClr val="A3BBD2"/>
                 </a:solidFill>
                 <a:latin typeface="Microsoft YaHei"/>
               </a:rPr>
-              <a:t>v3 test · 12 正例</a:t>
-            </a:r>
-          </a:p>
-        </p:txBody>
-      </p:sp>
-      <p:sp>
-        <p:nvSpPr>
-          <p:cNvPr id="9" name="Rounded Rectangle 8"/>
+              <a:t>13个旧集槽位；非独立请求</a:t>
+            </a:r>
+          </a:p>
+        </p:txBody>
+      </p:sp>
+      <p:sp>
+        <p:nvSpPr>
+          <p:cNvPr id="8" name="Rounded Rectangle 7"/>
           <p:cNvSpPr/>
           <p:nvPr/>
         </p:nvSpPr>
         <p:spPr>
           <a:xfrm>
-            <a:off x="3383280" y="1143000"/>
-            <a:ext cx="2606040" cy="1234440"/>
+            <a:off x="685800" y="1874519"/>
+            <a:ext cx="3383280" cy="576072"/>
           </a:xfrm>
           <a:prstGeom prst="roundRect">
             <a:avLst/>
@@ -4328,7 +4293,7 @@
           </a:solidFill>
           <a:ln w="15240">
             <a:solidFill>
-              <a:srgbClr val="5393FF"/>
+              <a:srgbClr val="183048"/>
             </a:solidFill>
           </a:ln>
         </p:spPr>
@@ -4352,27 +4317,27 @@
           <a:p>
             <a:pPr algn="ctr"/>
             <a:r>
-              <a:rPr sz="1700" b="1">
+              <a:rPr sz="1600" b="1">
                 <a:solidFill>
                   <a:srgbClr val="EEF6FF"/>
                 </a:solidFill>
                 <a:latin typeface="Microsoft YaHei"/>
               </a:rPr>
-              <a:t/>
-            </a:r>
-          </a:p>
-        </p:txBody>
-      </p:sp>
-      <p:sp>
-        <p:nvSpPr>
-          <p:cNvPr id="10" name="TextBox 9"/>
+              <a:t>知识召回率 ≥85%</a:t>
+            </a:r>
+          </a:p>
+        </p:txBody>
+      </p:sp>
+      <p:sp>
+        <p:nvSpPr>
+          <p:cNvPr id="9" name="TextBox 8"/>
           <p:cNvSpPr txBox="1"/>
           <p:nvPr/>
         </p:nvSpPr>
         <p:spPr>
           <a:xfrm>
-            <a:off x="3547872" y="1252728"/>
-            <a:ext cx="2276856" cy="274320"/>
+            <a:off x="4297680" y="1874519"/>
+            <a:ext cx="1874519" cy="576072"/>
           </a:xfrm>
           <a:prstGeom prst="rect">
             <a:avLst/>
@@ -4387,27 +4352,27 @@
           <a:p>
             <a:pPr algn="l"/>
             <a:r>
-              <a:rPr sz="1100" b="0">
-                <a:solidFill>
-                  <a:srgbClr val="A3BBD2"/>
-                </a:solidFill>
-                <a:latin typeface="Microsoft YaHei"/>
-              </a:rPr>
-              <a:t>无答案正确率</a:t>
-            </a:r>
-          </a:p>
-        </p:txBody>
-      </p:sp>
-      <p:sp>
-        <p:nvSpPr>
-          <p:cNvPr id="11" name="TextBox 10"/>
+              <a:rPr sz="2200" b="1">
+                <a:solidFill>
+                  <a:srgbClr val="FFC15C"/>
+                </a:solidFill>
+                <a:latin typeface="Microsoft YaHei"/>
+              </a:rPr>
+              <a:t>91.67%</a:t>
+            </a:r>
+          </a:p>
+        </p:txBody>
+      </p:sp>
+      <p:sp>
+        <p:nvSpPr>
+          <p:cNvPr id="10" name="TextBox 9"/>
           <p:cNvSpPr txBox="1"/>
           <p:nvPr/>
         </p:nvSpPr>
         <p:spPr>
           <a:xfrm>
-            <a:off x="3547872" y="1527048"/>
-            <a:ext cx="2276856" cy="438912"/>
+            <a:off x="6400800" y="1874519"/>
+            <a:ext cx="4846320" cy="576072"/>
           </a:xfrm>
           <a:prstGeom prst="rect">
             <a:avLst/>
@@ -4422,62 +4387,27 @@
           <a:p>
             <a:pPr algn="l"/>
             <a:r>
-              <a:rPr sz="2500" b="1">
-                <a:solidFill>
-                  <a:srgbClr val="5393FF"/>
-                </a:solidFill>
-                <a:latin typeface="Microsoft YaHei"/>
-              </a:rPr>
-              <a:t>1.0000</a:t>
-            </a:r>
-          </a:p>
-        </p:txBody>
-      </p:sp>
-      <p:sp>
-        <p:nvSpPr>
-          <p:cNvPr id="12" name="TextBox 11"/>
-          <p:cNvSpPr txBox="1"/>
-          <p:nvPr/>
-        </p:nvSpPr>
-        <p:spPr>
-          <a:xfrm>
-            <a:off x="3547872" y="2011680"/>
-            <a:ext cx="2276856" cy="228600"/>
-          </a:xfrm>
-          <a:prstGeom prst="rect">
-            <a:avLst/>
-          </a:prstGeom>
-          <a:noFill/>
-        </p:spPr>
-        <p:txBody>
-          <a:bodyPr wrap="square" anchor="ctr">
-            <a:spAutoFit/>
-          </a:bodyPr>
-          <a:lstStyle/>
-          <a:p>
-            <a:pPr algn="l"/>
-            <a:r>
-              <a:rPr sz="900" b="0">
+              <a:rPr sz="1500" b="0">
                 <a:solidFill>
                   <a:srgbClr val="A3BBD2"/>
                 </a:solidFill>
                 <a:latin typeface="Microsoft YaHei"/>
               </a:rPr>
-              <a:t>v3 test · 6 无答案</a:t>
-            </a:r>
-          </a:p>
-        </p:txBody>
-      </p:sp>
-      <p:sp>
-        <p:nvSpPr>
-          <p:cNvPr id="13" name="Rounded Rectangle 12"/>
+              <a:t>12个正例查询；不足50</a:t>
+            </a:r>
+          </a:p>
+        </p:txBody>
+      </p:sp>
+      <p:sp>
+        <p:nvSpPr>
+          <p:cNvPr id="11" name="Rounded Rectangle 10"/>
           <p:cNvSpPr/>
           <p:nvPr/>
         </p:nvSpPr>
         <p:spPr>
           <a:xfrm>
-            <a:off x="6172200" y="1143000"/>
-            <a:ext cx="2606040" cy="1234440"/>
+            <a:off x="685800" y="2670048"/>
+            <a:ext cx="3383280" cy="576072"/>
           </a:xfrm>
           <a:prstGeom prst="roundRect">
             <a:avLst/>
@@ -4487,7 +4417,7 @@
           </a:solidFill>
           <a:ln w="15240">
             <a:solidFill>
-              <a:srgbClr val="63DE8B"/>
+              <a:srgbClr val="183048"/>
             </a:solidFill>
           </a:ln>
         </p:spPr>
@@ -4511,27 +4441,27 @@
           <a:p>
             <a:pPr algn="ctr"/>
             <a:r>
-              <a:rPr sz="1700" b="1">
+              <a:rPr sz="1600" b="1">
                 <a:solidFill>
                   <a:srgbClr val="EEF6FF"/>
                 </a:solidFill>
                 <a:latin typeface="Microsoft YaHei"/>
               </a:rPr>
-              <a:t/>
-            </a:r>
-          </a:p>
-        </p:txBody>
-      </p:sp>
-      <p:sp>
-        <p:nvSpPr>
-          <p:cNvPr id="14" name="TextBox 13"/>
+              <a:t>冲突正确率 ≥88%</a:t>
+            </a:r>
+          </a:p>
+        </p:txBody>
+      </p:sp>
+      <p:sp>
+        <p:nvSpPr>
+          <p:cNvPr id="12" name="TextBox 11"/>
           <p:cNvSpPr txBox="1"/>
           <p:nvPr/>
         </p:nvSpPr>
         <p:spPr>
           <a:xfrm>
-            <a:off x="6336792" y="1252728"/>
-            <a:ext cx="2276856" cy="274320"/>
+            <a:off x="4297680" y="2670048"/>
+            <a:ext cx="1874519" cy="576072"/>
           </a:xfrm>
           <a:prstGeom prst="rect">
             <a:avLst/>
@@ -4546,27 +4476,27 @@
           <a:p>
             <a:pPr algn="l"/>
             <a:r>
-              <a:rPr sz="1100" b="0">
-                <a:solidFill>
-                  <a:srgbClr val="A3BBD2"/>
-                </a:solidFill>
-                <a:latin typeface="Microsoft YaHei"/>
-              </a:rPr>
-              <a:t>平衡得分</a:t>
-            </a:r>
-          </a:p>
-        </p:txBody>
-      </p:sp>
-      <p:sp>
-        <p:nvSpPr>
-          <p:cNvPr id="15" name="TextBox 14"/>
+              <a:rPr sz="2200" b="1">
+                <a:solidFill>
+                  <a:srgbClr val="FFC15C"/>
+                </a:solidFill>
+                <a:latin typeface="Microsoft YaHei"/>
+              </a:rPr>
+              <a:t>100.00%</a:t>
+            </a:r>
+          </a:p>
+        </p:txBody>
+      </p:sp>
+      <p:sp>
+        <p:nvSpPr>
+          <p:cNvPr id="13" name="TextBox 12"/>
           <p:cNvSpPr txBox="1"/>
           <p:nvPr/>
         </p:nvSpPr>
         <p:spPr>
           <a:xfrm>
-            <a:off x="6336792" y="1527048"/>
-            <a:ext cx="2276856" cy="438912"/>
+            <a:off x="6400800" y="2670048"/>
+            <a:ext cx="4846320" cy="576072"/>
           </a:xfrm>
           <a:prstGeom prst="rect">
             <a:avLst/>
@@ -4581,62 +4511,27 @@
           <a:p>
             <a:pPr algn="l"/>
             <a:r>
-              <a:rPr sz="2500" b="1">
-                <a:solidFill>
-                  <a:srgbClr val="63DE8B"/>
-                </a:solidFill>
-                <a:latin typeface="Microsoft YaHei"/>
-              </a:rPr>
-              <a:t>0.9583</a:t>
-            </a:r>
-          </a:p>
-        </p:txBody>
-      </p:sp>
-      <p:sp>
-        <p:nvSpPr>
-          <p:cNvPr id="16" name="TextBox 15"/>
-          <p:cNvSpPr txBox="1"/>
-          <p:nvPr/>
-        </p:nvSpPr>
-        <p:spPr>
-          <a:xfrm>
-            <a:off x="6336792" y="2011680"/>
-            <a:ext cx="2276856" cy="228600"/>
-          </a:xfrm>
-          <a:prstGeom prst="rect">
-            <a:avLst/>
-          </a:prstGeom>
-          <a:noFill/>
-        </p:spPr>
-        <p:txBody>
-          <a:bodyPr wrap="square" anchor="ctr">
-            <a:spAutoFit/>
-          </a:bodyPr>
-          <a:lstStyle/>
-          <a:p>
-            <a:pPr algn="l"/>
-            <a:r>
-              <a:rPr sz="900" b="0">
+              <a:rPr sz="1500" b="0">
                 <a:solidFill>
                   <a:srgbClr val="A3BBD2"/>
                 </a:solidFill>
                 <a:latin typeface="Microsoft YaHei"/>
               </a:rPr>
-              <a:t>召回与拒答平均</a:t>
-            </a:r>
-          </a:p>
-        </p:txBody>
-      </p:sp>
-      <p:sp>
-        <p:nvSpPr>
-          <p:cNvPr id="17" name="Rounded Rectangle 16"/>
+              <a:t>2个案例；不足50</a:t>
+            </a:r>
+          </a:p>
+        </p:txBody>
+      </p:sp>
+      <p:sp>
+        <p:nvSpPr>
+          <p:cNvPr id="14" name="Rounded Rectangle 13"/>
           <p:cNvSpPr/>
           <p:nvPr/>
         </p:nvSpPr>
         <p:spPr>
           <a:xfrm>
-            <a:off x="8961120" y="1143000"/>
-            <a:ext cx="2606040" cy="1234440"/>
+            <a:off x="685800" y="3465576"/>
+            <a:ext cx="3383280" cy="576072"/>
           </a:xfrm>
           <a:prstGeom prst="roundRect">
             <a:avLst/>
@@ -4646,7 +4541,7 @@
           </a:solidFill>
           <a:ln w="15240">
             <a:solidFill>
-              <a:srgbClr val="45DEC4"/>
+              <a:srgbClr val="183048"/>
             </a:solidFill>
           </a:ln>
         </p:spPr>
@@ -4670,27 +4565,27 @@
           <a:p>
             <a:pPr algn="ctr"/>
             <a:r>
-              <a:rPr sz="1700" b="1">
+              <a:rPr sz="1600" b="1">
                 <a:solidFill>
                   <a:srgbClr val="EEF6FF"/>
                 </a:solidFill>
                 <a:latin typeface="Microsoft YaHei"/>
               </a:rPr>
-              <a:t/>
-            </a:r>
-          </a:p>
-        </p:txBody>
-      </p:sp>
-      <p:sp>
-        <p:nvSpPr>
-          <p:cNvPr id="18" name="TextBox 17"/>
+              <a:t>检索P95 ≤500ms</a:t>
+            </a:r>
+          </a:p>
+        </p:txBody>
+      </p:sp>
+      <p:sp>
+        <p:nvSpPr>
+          <p:cNvPr id="15" name="TextBox 14"/>
           <p:cNvSpPr txBox="1"/>
           <p:nvPr/>
         </p:nvSpPr>
         <p:spPr>
           <a:xfrm>
-            <a:off x="9125712" y="1252728"/>
-            <a:ext cx="2276856" cy="274320"/>
+            <a:off x="4297680" y="3465576"/>
+            <a:ext cx="1874519" cy="576072"/>
           </a:xfrm>
           <a:prstGeom prst="rect">
             <a:avLst/>
@@ -4705,27 +4600,27 @@
           <a:p>
             <a:pPr algn="l"/>
             <a:r>
-              <a:rPr sz="1100" b="0">
-                <a:solidFill>
-                  <a:srgbClr val="A3BBD2"/>
-                </a:solidFill>
-                <a:latin typeface="Microsoft YaHei"/>
-              </a:rPr>
-              <a:t>内部质量目标</a:t>
-            </a:r>
-          </a:p>
-        </p:txBody>
-      </p:sp>
-      <p:sp>
-        <p:nvSpPr>
-          <p:cNvPr id="19" name="TextBox 18"/>
+              <a:rPr sz="2200" b="1">
+                <a:solidFill>
+                  <a:srgbClr val="FFC15C"/>
+                </a:solidFill>
+                <a:latin typeface="Microsoft YaHei"/>
+              </a:rPr>
+              <a:t>190.57 ms</a:t>
+            </a:r>
+          </a:p>
+        </p:txBody>
+      </p:sp>
+      <p:sp>
+        <p:nvSpPr>
+          <p:cNvPr id="16" name="TextBox 15"/>
           <p:cNvSpPr txBox="1"/>
           <p:nvPr/>
         </p:nvSpPr>
         <p:spPr>
           <a:xfrm>
-            <a:off x="9125712" y="1527048"/>
-            <a:ext cx="2276856" cy="438912"/>
+            <a:off x="6400800" y="3465576"/>
+            <a:ext cx="4846320" cy="576072"/>
           </a:xfrm>
           <a:prstGeom prst="rect">
             <a:avLst/>
@@ -4740,168 +4635,27 @@
           <a:p>
             <a:pPr algn="l"/>
             <a:r>
-              <a:rPr sz="2500" b="1">
-                <a:solidFill>
-                  <a:srgbClr val="45DEC4"/>
-                </a:solidFill>
-                <a:latin typeface="Microsoft YaHei"/>
-              </a:rPr>
-              <a:t>两项已满足</a:t>
-            </a:r>
-          </a:p>
-        </p:txBody>
-      </p:sp>
-      <p:sp>
-        <p:nvSpPr>
-          <p:cNvPr id="20" name="TextBox 19"/>
-          <p:cNvSpPr txBox="1"/>
-          <p:nvPr/>
-        </p:nvSpPr>
-        <p:spPr>
-          <a:xfrm>
-            <a:off x="9125712" y="2011680"/>
-            <a:ext cx="2276856" cy="228600"/>
-          </a:xfrm>
-          <a:prstGeom prst="rect">
-            <a:avLst/>
-          </a:prstGeom>
-          <a:noFill/>
-        </p:spPr>
-        <p:txBody>
-          <a:bodyPr wrap="square" anchor="ctr">
-            <a:spAutoFit/>
-          </a:bodyPr>
-          <a:lstStyle/>
-          <a:p>
-            <a:pPr algn="l"/>
-            <a:r>
-              <a:rPr sz="900" b="0">
+              <a:rPr sz="1500" b="0">
                 <a:solidFill>
                   <a:srgbClr val="A3BBD2"/>
                 </a:solidFill>
                 <a:latin typeface="Microsoft YaHei"/>
               </a:rPr>
-              <a:t>两项分别 ≥ 0.85</a:t>
-            </a:r>
-          </a:p>
-        </p:txBody>
-      </p:sp>
-      <p:sp>
-        <p:nvSpPr>
-          <p:cNvPr id="21" name="TextBox 20"/>
-          <p:cNvSpPr txBox="1"/>
-          <p:nvPr/>
-        </p:nvSpPr>
-        <p:spPr>
-          <a:xfrm>
-            <a:off x="685800" y="2907792"/>
-            <a:ext cx="5303520" cy="411480"/>
-          </a:xfrm>
-          <a:prstGeom prst="rect">
-            <a:avLst/>
-          </a:prstGeom>
-          <a:noFill/>
-        </p:spPr>
-        <p:txBody>
-          <a:bodyPr wrap="square" anchor="ctr">
-            <a:spAutoFit/>
-          </a:bodyPr>
-          <a:lstStyle/>
-          <a:p>
-            <a:pPr algn="l"/>
-            <a:r>
-              <a:rPr sz="2200" b="1">
-                <a:solidFill>
-                  <a:srgbClr val="EEF6FF"/>
-                </a:solidFill>
-                <a:latin typeface="Microsoft YaHei"/>
-              </a:rPr>
-              <a:t>42 事件 · 18 主题 · 54 查询</a:t>
-            </a:r>
-          </a:p>
-        </p:txBody>
-      </p:sp>
-      <p:sp>
-        <p:nvSpPr>
-          <p:cNvPr id="22" name="TextBox 21"/>
-          <p:cNvSpPr txBox="1"/>
-          <p:nvPr/>
-        </p:nvSpPr>
-        <p:spPr>
-          <a:xfrm>
-            <a:off x="685800" y="3401568"/>
-            <a:ext cx="5303520" cy="2011680"/>
-          </a:xfrm>
-          <a:prstGeom prst="rect">
-            <a:avLst/>
-          </a:prstGeom>
-          <a:noFill/>
-        </p:spPr>
-        <p:txBody>
-          <a:bodyPr wrap="square">
-            <a:spAutoFit/>
-          </a:bodyPr>
-          <a:lstStyle/>
-          <a:p>
-            <a:pPr>
-              <a:spcAft>
-                <a:spcPts val="1100"/>
-              </a:spcAft>
-              <a:defRPr sz="1500">
-                <a:solidFill>
-                  <a:srgbClr val="EEF6FF"/>
-                </a:solidFill>
-                <a:latin typeface="Microsoft YaHei"/>
-              </a:defRPr>
-            </a:pPr>
-            <a:r>
-              <a:t>•  正文/模板族跨分区交集为零</a:t>
-            </a:r>
-          </a:p>
-          <a:p>
-            <a:pPr>
-              <a:spcAft>
-                <a:spcPts val="1100"/>
-              </a:spcAft>
-              <a:defRPr sz="1500">
-                <a:solidFill>
-                  <a:srgbClr val="EEF6FF"/>
-                </a:solidFill>
-                <a:latin typeface="Microsoft YaHei"/>
-              </a:defRPr>
-            </a:pPr>
-            <a:r>
-              <a:t>•  统一阈值 0.265 仅由 dev 选择</a:t>
-            </a:r>
-          </a:p>
-          <a:p>
-            <a:pPr>
-              <a:spcAft>
-                <a:spcPts val="1100"/>
-              </a:spcAft>
-              <a:defRPr sz="1500">
-                <a:solidFill>
-                  <a:srgbClr val="EEF6FF"/>
-                </a:solidFill>
-                <a:latin typeface="Microsoft YaHei"/>
-              </a:defRPr>
-            </a:pPr>
-            <a:r>
-              <a:t>•  词法/向量/混合对照：不宣称全面领先</a:t>
-            </a:r>
-          </a:p>
-        </p:txBody>
-      </p:sp>
-      <p:sp>
-        <p:nvSpPr>
-          <p:cNvPr id="23" name="Rounded Rectangle 22"/>
+              <a:t>50主题请求；HashEmbedding</a:t>
+            </a:r>
+          </a:p>
+        </p:txBody>
+      </p:sp>
+      <p:sp>
+        <p:nvSpPr>
+          <p:cNvPr id="17" name="Rounded Rectangle 16"/>
           <p:cNvSpPr/>
           <p:nvPr/>
         </p:nvSpPr>
         <p:spPr>
           <a:xfrm>
-            <a:off x="6400800" y="2926080"/>
-            <a:ext cx="5074920" cy="2194560"/>
+            <a:off x="685800" y="4261104"/>
+            <a:ext cx="3383280" cy="576072"/>
           </a:xfrm>
           <a:prstGeom prst="roundRect">
             <a:avLst/>
@@ -4911,7 +4665,7 @@
           </a:solidFill>
           <a:ln w="15240">
             <a:solidFill>
-              <a:srgbClr val="FF6F7E"/>
+              <a:srgbClr val="183048"/>
             </a:solidFill>
           </a:ln>
         </p:spPr>
@@ -4935,29 +4689,27 @@
           <a:p>
             <a:pPr algn="ctr"/>
             <a:r>
-              <a:rPr sz="2200" b="1">
-                <a:solidFill>
-                  <a:srgbClr val="FF6F7E"/>
-                </a:solidFill>
-                <a:latin typeface="Microsoft YaHei"/>
-              </a:rPr>
-              <a:t>公开 test 标签
-= 冻结回归分区
-≠ 第三方独立盲测</a:t>
-            </a:r>
-          </a:p>
-        </p:txBody>
-      </p:sp>
-      <p:sp>
-        <p:nvSpPr>
-          <p:cNvPr id="24" name="TextBox 23"/>
+              <a:rPr sz="1600" b="1">
+                <a:solidFill>
+                  <a:srgbClr val="EEF6FF"/>
+                </a:solidFill>
+                <a:latin typeface="Microsoft YaHei"/>
+              </a:rPr>
+              <a:t>敏感F1 ≥90%</a:t>
+            </a:r>
+          </a:p>
+        </p:txBody>
+      </p:sp>
+      <p:sp>
+        <p:nvSpPr>
+          <p:cNvPr id="18" name="TextBox 17"/>
           <p:cNvSpPr txBox="1"/>
           <p:nvPr/>
         </p:nvSpPr>
         <p:spPr>
           <a:xfrm>
-            <a:off x="685800" y="5806440"/>
-            <a:ext cx="10789920" cy="292608"/>
+            <a:off x="4297680" y="4261104"/>
+            <a:ext cx="1874519" cy="576072"/>
           </a:xfrm>
           <a:prstGeom prst="rect">
             <a:avLst/>
@@ -4970,15 +4722,139 @@
           </a:bodyPr>
           <a:lstStyle/>
           <a:p>
+            <a:pPr algn="l"/>
+            <a:r>
+              <a:rPr sz="2200" b="1">
+                <a:solidFill>
+                  <a:srgbClr val="FFC15C"/>
+                </a:solidFill>
+                <a:latin typeface="Microsoft YaHei"/>
+              </a:rPr>
+              <a:t>100.00%</a:t>
+            </a:r>
+          </a:p>
+        </p:txBody>
+      </p:sp>
+      <p:sp>
+        <p:nvSpPr>
+          <p:cNvPr id="19" name="TextBox 18"/>
+          <p:cNvSpPr txBox="1"/>
+          <p:nvPr/>
+        </p:nvSpPr>
+        <p:spPr>
+          <a:xfrm>
+            <a:off x="6400800" y="4261104"/>
+            <a:ext cx="4846320" cy="576072"/>
+          </a:xfrm>
+          <a:prstGeom prst="rect">
+            <a:avLst/>
+          </a:prstGeom>
+          <a:noFill/>
+        </p:spPr>
+        <p:txBody>
+          <a:bodyPr wrap="square" anchor="ctr">
+            <a:spAutoFit/>
+          </a:bodyPr>
+          <a:lstStyle/>
+          <a:p>
+            <a:pPr algn="l"/>
+            <a:r>
+              <a:rPr sz="1500" b="0">
+                <a:solidFill>
+                  <a:srgbClr val="A3BBD2"/>
+                </a:solidFill>
+                <a:latin typeface="Microsoft YaHei"/>
+              </a:rPr>
+              <a:t>50合成请求；请求级分类</a:t>
+            </a:r>
+          </a:p>
+        </p:txBody>
+      </p:sp>
+      <p:sp>
+        <p:nvSpPr>
+          <p:cNvPr id="20" name="Rounded Rectangle 19"/>
+          <p:cNvSpPr/>
+          <p:nvPr/>
+        </p:nvSpPr>
+        <p:spPr>
+          <a:xfrm>
+            <a:off x="731520" y="5212080"/>
+            <a:ext cx="10698480" cy="685800"/>
+          </a:xfrm>
+          <a:prstGeom prst="roundRect">
+            <a:avLst/>
+          </a:prstGeom>
+          <a:solidFill>
+            <a:srgbClr val="112235"/>
+          </a:solidFill>
+          <a:ln w="15240">
+            <a:solidFill>
+              <a:srgbClr val="FFC15C"/>
+            </a:solidFill>
+          </a:ln>
+        </p:spPr>
+        <p:style>
+          <a:lnRef idx="1">
+            <a:schemeClr val="accent1"/>
+          </a:lnRef>
+          <a:fillRef idx="3">
+            <a:schemeClr val="accent1"/>
+          </a:fillRef>
+          <a:effectRef idx="2">
+            <a:schemeClr val="accent1"/>
+          </a:effectRef>
+          <a:fontRef idx="minor">
+            <a:schemeClr val="lt1"/>
+          </a:fontRef>
+        </p:style>
+        <p:txBody>
+          <a:bodyPr rtlCol="0" anchor="ctr" wrap="square"/>
+          <a:lstStyle/>
+          <a:p>
             <a:pPr algn="ctr"/>
             <a:r>
-              <a:rPr sz="1400" b="1">
+              <a:rPr sz="1700" b="1">
                 <a:solidFill>
                   <a:srgbClr val="FFC15C"/>
                 </a:solidFill>
                 <a:latin typeface="Microsoft YaHei"/>
               </a:rPr>
-              <a:t>合成小集上的 1.0 不能外推到开放真实数据</a:t>
+              <a:t>官方尚未就绪：V11强制部署 + 每项至少50独立请求 + 真实评测</a:t>
+            </a:r>
+          </a:p>
+        </p:txBody>
+      </p:sp>
+      <p:sp>
+        <p:nvSpPr>
+          <p:cNvPr id="21" name="TextBox 20"/>
+          <p:cNvSpPr txBox="1"/>
+          <p:nvPr/>
+        </p:nvSpPr>
+        <p:spPr>
+          <a:xfrm>
+            <a:off x="731520" y="5943600"/>
+            <a:ext cx="10698480" cy="320040"/>
+          </a:xfrm>
+          <a:prstGeom prst="rect">
+            <a:avLst/>
+          </a:prstGeom>
+          <a:noFill/>
+        </p:spPr>
+        <p:txBody>
+          <a:bodyPr wrap="square" anchor="ctr">
+            <a:spAutoFit/>
+          </a:bodyPr>
+          <a:lstStyle/>
+          <a:p>
+            <a:pPr algn="l"/>
+            <a:r>
+              <a:rPr sz="1200" b="0">
+                <a:solidFill>
+                  <a:srgbClr val="A3BBD2"/>
+                </a:solidFill>
+                <a:latin typeface="Microsoft YaHei"/>
+              </a:rPr>
+              <a:t>历史召回91.67%与无答案100%不等于官方两个85%均达标；行动替身15/15仅为框架自检</a:t>
             </a:r>
           </a:p>
         </p:txBody>
@@ -5233,7 +5109,7 @@
                 </a:solidFill>
                 <a:latin typeface="Microsoft YaHei"/>
               </a:rPr>
-              <a:t>91 项通过</a:t>
+              <a:t>115</a:t>
             </a:r>
           </a:p>
         </p:txBody>
@@ -5268,7 +5144,7 @@
                 </a:solidFill>
                 <a:latin typeface="Microsoft YaHei"/>
               </a:rPr>
-              <a:t>单元 + 集成 + E2E</a:t>
+              <a:t>测试数；通过状态见原始报告</a:t>
             </a:r>
           </a:p>
         </p:txBody>
@@ -6785,7 +6661,7 @@
                 </a:solidFill>
                 <a:latin typeface="Microsoft YaHei"/>
               </a:rPr>
-              <a:t>v3 对照、91 测试、10k 性能</a:t>
+              <a:t>v3 对照、115 测试、10k 性能</a:t>
             </a:r>
           </a:p>
         </p:txBody>
@@ -7040,7 +6916,7 @@
                 </a:solidFill>
                 <a:latin typeface="Microsoft YaHei"/>
               </a:rPr>
-              <a:t>必须人工/外部完成</a:t>
+              <a:t>继续验证与补齐</a:t>
             </a:r>
           </a:p>
         </p:txBody>
@@ -7418,7 +7294,7 @@
                 </a:solidFill>
                 <a:latin typeface="Microsoft YaHei"/>
               </a:rPr>
-              <a:t>!  真实 Kylin SDK</a:t>
+              <a:t>!  真实SDK/向量服务联调</a:t>
             </a:r>
           </a:p>
         </p:txBody>
@@ -7472,7 +7348,7 @@
                 </a:solidFill>
                 <a:latin typeface="Microsoft YaHei"/>
               </a:rPr>
-              <a:t>!  真实银河麒麟</a:t>
+              <a:t>!  V11虚拟机赛事认可</a:t>
             </a:r>
           </a:p>
         </p:txBody>
@@ -7526,7 +7402,7 @@
                 </a:solidFill>
                 <a:latin typeface="Microsoft YaHei"/>
               </a:rPr>
-              <a:t>!  独立盲测</a:t>
+              <a:t>!  独立盲测与LLM Judge</a:t>
             </a:r>
           </a:p>
         </p:txBody>
@@ -13850,7 +13726,7 @@
                 </a:solidFill>
                 <a:latin typeface="Microsoft YaHei"/>
               </a:rPr>
-              <a:t>10,000 条热 p99</a:t>
+              <a:t>第三轮10,000条热p99</a:t>
             </a:r>
           </a:p>
         </p:txBody>
@@ -13920,7 +13796,7 @@
                 </a:solidFill>
                 <a:latin typeface="Microsoft YaHei"/>
               </a:rPr>
-              <a:t>门槛：≤ 500ms</a:t>
+              <a:t>历史内部结果；官方使用P95</a:t>
             </a:r>
           </a:p>
         </p:txBody>

</xml_diff>

<commit_message>
docs: synchronize fifth-round evidence and editable deliverables
</commit_message>
<xml_diff>
--- a/deliverables/ppt/OS_Agent_记忆优化_答辩稿.pptx
+++ b/deliverables/ppt/OS_Agent_记忆优化_答辩稿.pptx
@@ -3308,7 +3308,7 @@
                 </a:solidFill>
                 <a:latin typeface="Microsoft YaHei"/>
               </a:rPr>
-              <a:t>核心原型与开发机验证完成</a:t>
+              <a:t>Windows / V11 内部回归</a:t>
             </a:r>
           </a:p>
         </p:txBody>
@@ -3362,7 +3362,7 @@
                 </a:solidFill>
                 <a:latin typeface="Microsoft YaHei"/>
               </a:rPr>
-              <a:t>V11 实测与 SDK 分开验收</a:t>
+              <a:t>正式提交仍为 INCOMPLETE</a:t>
             </a:r>
           </a:p>
         </p:txBody>
@@ -3397,7 +3397,7 @@
                 </a:solidFill>
                 <a:latin typeface="Microsoft YaHei"/>
               </a:rPr>
-              <a:t>第四轮官方口径整改稿 · 2026-09-07</a:t>
+              <a:t>第五轮逐请求实测稿 · 2026-09-07</a:t>
             </a:r>
           </a:p>
         </p:txBody>
@@ -4075,7 +4075,7 @@
                 </a:solidFill>
                 <a:latin typeface="Microsoft YaHei"/>
               </a:rPr>
-              <a:t>10  官方五项指标：当前内部证据与缺口</a:t>
+              <a:t>10  冻结逐请求五项：内部达标，非官方认证</a:t>
             </a:r>
           </a:p>
         </p:txBody>
@@ -4234,7 +4234,7 @@
                 </a:solidFill>
                 <a:latin typeface="Microsoft YaHei"/>
               </a:rPr>
-              <a:t>46.15%</a:t>
+              <a:t>100.00%</a:t>
             </a:r>
           </a:p>
         </p:txBody>
@@ -4269,7 +4269,7 @@
                 </a:solidFill>
                 <a:latin typeface="Microsoft YaHei"/>
               </a:rPr>
-              <a:t>13个旧集槽位；非独立请求</a:t>
+              <a:t>68 请求；完整键值集合匹配</a:t>
             </a:r>
           </a:p>
         </p:txBody>
@@ -4358,7 +4358,7 @@
                 </a:solidFill>
                 <a:latin typeface="Microsoft YaHei"/>
               </a:rPr>
-              <a:t>91.67%</a:t>
+              <a:t>100.00%</a:t>
             </a:r>
           </a:p>
         </p:txBody>
@@ -4393,7 +4393,7 @@
                 </a:solidFill>
                 <a:latin typeface="Microsoft YaHei"/>
               </a:rPr>
-              <a:t>12个正例查询；不足50</a:t>
+              <a:t>60 正例；另查无答案/跨域</a:t>
             </a:r>
           </a:p>
         </p:txBody>
@@ -4517,7 +4517,7 @@
                 </a:solidFill>
                 <a:latin typeface="Microsoft YaHei"/>
               </a:rPr>
-              <a:t>2个案例；不足50</a:t>
+              <a:t>60 对；检测和最终状态联合</a:t>
             </a:r>
           </a:p>
         </p:txBody>
@@ -4606,7 +4606,7 @@
                 </a:solidFill>
                 <a:latin typeface="Microsoft YaHei"/>
               </a:rPr>
-              <a:t>190.57 ms</a:t>
+              <a:t>67.320 ms</a:t>
             </a:r>
           </a:p>
         </p:txBody>
@@ -4641,7 +4641,7 @@
                 </a:solidFill>
                 <a:latin typeface="Microsoft YaHei"/>
               </a:rPr>
-              <a:t>50主题请求；HashEmbedding</a:t>
+              <a:t>80 查询；10,000 条 / Hash</a:t>
             </a:r>
           </a:p>
         </p:txBody>
@@ -4765,7 +4765,7 @@
                 </a:solidFill>
                 <a:latin typeface="Microsoft YaHei"/>
               </a:rPr>
-              <a:t>50合成请求；请求级分类</a:t>
+              <a:t>50 请求；实体 TP30/FP0/FN0</a:t>
             </a:r>
           </a:p>
         </p:txBody>
@@ -4789,7 +4789,7 @@
           </a:solidFill>
           <a:ln w="15240">
             <a:solidFill>
-              <a:srgbClr val="FFC15C"/>
+              <a:srgbClr val="45DEC4"/>
             </a:solidFill>
           </a:ln>
         </p:spPr>
@@ -4815,11 +4815,11 @@
             <a:r>
               <a:rPr sz="1700" b="1">
                 <a:solidFill>
-                  <a:srgbClr val="FFC15C"/>
-                </a:solidFill>
-                <a:latin typeface="Microsoft YaHei"/>
-              </a:rPr>
-              <a:t>官方尚未就绪：V11强制部署 + 每项至少50独立请求 + 真实评测</a:t>
+                  <a:srgbClr val="45DEC4"/>
+                </a:solidFill>
+                <a:latin typeface="Microsoft YaHei"/>
+              </a:rPr>
+              <a:t>上表 Windows；V11 同套五项也通过，原始报告分别保存</a:t>
             </a:r>
           </a:p>
         </p:txBody>
@@ -4854,7 +4854,7 @@
                 </a:solidFill>
                 <a:latin typeface="Microsoft YaHei"/>
               </a:rPr>
-              <a:t>历史召回91.67%与无答案100%不等于官方两个85%均达标；行动替身15/15仅为框架自检</a:t>
+              <a:t>公开合成标签由开发者持有；保留失败基线；不等于第三方盲测、真实Agent或官方认证</a:t>
             </a:r>
           </a:p>
         </p:txBody>
@@ -5074,7 +5074,7 @@
                 </a:solidFill>
                 <a:latin typeface="Microsoft YaHei"/>
               </a:rPr>
-              <a:t>自动化测试</a:t>
+              <a:t>Windows 自动化测试</a:t>
             </a:r>
           </a:p>
         </p:txBody>
@@ -5109,7 +5109,7 @@
                 </a:solidFill>
                 <a:latin typeface="Microsoft YaHei"/>
               </a:rPr>
-              <a:t>115</a:t>
+              <a:t>146</a:t>
             </a:r>
           </a:p>
         </p:txBody>
@@ -5144,7 +5144,7 @@
                 </a:solidFill>
                 <a:latin typeface="Microsoft YaHei"/>
               </a:rPr>
-              <a:t>测试数；通过状态见原始报告</a:t>
+              <a:t>通过状态与源码摘要见报告</a:t>
             </a:r>
           </a:p>
         </p:txBody>
@@ -5233,7 +5233,7 @@
                 </a:solidFill>
                 <a:latin typeface="Microsoft YaHei"/>
               </a:rPr>
-              <a:t>规模覆盖</a:t>
+              <a:t>V11 客户机自动化测试</a:t>
             </a:r>
           </a:p>
         </p:txBody>
@@ -5268,7 +5268,7 @@
                 </a:solidFill>
                 <a:latin typeface="Microsoft YaHei"/>
               </a:rPr>
-              <a:t>100 → 10,000</a:t>
+              <a:t>134</a:t>
             </a:r>
           </a:p>
         </p:txBody>
@@ -5303,7 +5303,7 @@
                 </a:solidFill>
                 <a:latin typeface="Microsoft YaHei"/>
               </a:rPr>
-              <a:t>冷/热/资源/磁盘</a:t>
+              <a:t>磁盘安装 / VMware / 离线</a:t>
             </a:r>
           </a:p>
         </p:txBody>
@@ -5392,7 +5392,7 @@
                 </a:solidFill>
                 <a:latin typeface="Microsoft YaHei"/>
               </a:rPr>
-              <a:t>环境判定</a:t>
+              <a:t>真实 SDK 单探针</a:t>
             </a:r>
           </a:p>
         </p:txBody>
@@ -5427,7 +5427,7 @@
                 </a:solidFill>
                 <a:latin typeface="Microsoft YaHei"/>
               </a:rPr>
-              <a:t>分层报告</a:t>
+              <a:t>768 维</a:t>
             </a:r>
           </a:p>
         </p:txBody>
@@ -5462,7 +5462,7 @@
                 </a:solidFill>
                 <a:latin typeface="Microsoft YaHei"/>
               </a:rPr>
-              <a:t>本地 ≠ 麒麟 ≠ SDK</a:t>
+              <a:t>身份/质量/性能仍待验证</a:t>
             </a:r>
           </a:p>
         </p:txBody>
@@ -6661,7 +6661,7 @@
                 </a:solidFill>
                 <a:latin typeface="Microsoft YaHei"/>
               </a:rPr>
-              <a:t>v3 对照、115 测试、10k 性能</a:t>
+              <a:t>五项逐请求、146 测试、V11 报告</a:t>
             </a:r>
           </a:p>
         </p:txBody>
@@ -6881,7 +6881,7 @@
                 </a:solidFill>
                 <a:latin typeface="Microsoft YaHei"/>
               </a:rPr>
-              <a:t>已完成（代码与开发机证据）</a:t>
+              <a:t>已完成（可复现内部证据）</a:t>
             </a:r>
           </a:p>
         </p:txBody>
@@ -6970,7 +6970,7 @@
                 </a:solidFill>
                 <a:latin typeface="Microsoft YaHei"/>
               </a:rPr>
-              <a:t>✓  统一生命周期门控</a:t>
+              <a:t>✓  生命周期/显式授权门控</a:t>
             </a:r>
           </a:p>
         </p:txBody>
@@ -7132,7 +7132,7 @@
                 </a:solidFill>
                 <a:latin typeface="Microsoft YaHei"/>
               </a:rPr>
-              <a:t>✓  v3 隔离分区与对照</a:t>
+              <a:t>✓  冻结逐请求五项回归</a:t>
             </a:r>
           </a:p>
         </p:txBody>
@@ -7186,7 +7186,7 @@
                 </a:solidFill>
                 <a:latin typeface="Microsoft YaHei"/>
               </a:rPr>
-              <a:t>✓  10k 检索 + 实际服务负载</a:t>
+              <a:t>✓  V11磁盘安装与客户机实测</a:t>
             </a:r>
           </a:p>
         </p:txBody>
@@ -7240,7 +7240,7 @@
                 </a:solidFill>
                 <a:latin typeface="Microsoft YaHei"/>
               </a:rPr>
-              <a:t>✓  作用域与重启安全测试</a:t>
+              <a:t>✓  旧ABI真实向量单探针</a:t>
             </a:r>
           </a:p>
         </p:txBody>
@@ -7294,7 +7294,7 @@
                 </a:solidFill>
                 <a:latin typeface="Microsoft YaHei"/>
               </a:rPr>
-              <a:t>!  真实SDK/向量服务联调</a:t>
+              <a:t>!  原生模型身份/向量库往返</a:t>
             </a:r>
           </a:p>
         </p:txBody>
@@ -7402,7 +7402,7 @@
                 </a:solidFill>
                 <a:latin typeface="Microsoft YaHei"/>
               </a:rPr>
-              <a:t>!  独立盲测与LLM Judge</a:t>
+              <a:t>!  真实Agent与独立LLM Judge</a:t>
             </a:r>
           </a:p>
         </p:txBody>
@@ -7510,7 +7510,7 @@
                 </a:solidFill>
                 <a:latin typeface="Microsoft YaHei"/>
               </a:rPr>
-              <a:t>!  最终视频</a:t>
+              <a:t>!  最终视频（不超过7分钟）</a:t>
             </a:r>
           </a:p>
         </p:txBody>
@@ -7564,7 +7564,7 @@
                 </a:solidFill>
                 <a:latin typeface="Microsoft YaHei"/>
               </a:rPr>
-              <a:t>!  平台/邮件回执</a:t>
+              <a:t>!  平台/报名/邮件回执</a:t>
             </a:r>
           </a:p>
         </p:txBody>
@@ -7599,7 +7599,7 @@
                 </a:solidFill>
                 <a:latin typeface="Microsoft YaHei"/>
               </a:rPr>
-              <a:t>当前准确表述：核心原型与开发机验证完成，赛题指定环境待验收</a:t>
+              <a:t>当前准确表述：Windows/V11 内部回归达标；外部赛事验收尚未完成</a:t>
             </a:r>
           </a:p>
         </p:txBody>
@@ -8013,7 +8013,7 @@
                 </a:solidFill>
                 <a:latin typeface="Microsoft YaHei"/>
               </a:rPr>
-              <a:t>候选合并 + 向量缓存；10k 开发机 p99 362.265ms</a:t>
+              <a:t>候选合并 + 向量缓存；V11 P95 111.626ms（Hash）</a:t>
             </a:r>
           </a:p>
         </p:txBody>
@@ -8191,7 +8191,7 @@
                 </a:solidFill>
                 <a:latin typeface="Microsoft YaHei"/>
               </a:rPr>
-              <a:t>下一步：真实 SDK × 真实银河麒麟 × 独立盲测 × 授权案例</a:t>
+              <a:t>下一步：原生模型复测 × 真实Agent × 独立盲测 × 授权案例</a:t>
             </a:r>
           </a:p>
         </p:txBody>
@@ -13567,7 +13567,7 @@
                 </a:solidFill>
                 <a:latin typeface="Microsoft YaHei"/>
               </a:rPr>
-              <a:t>10,000 条冷查询</a:t>
+              <a:t>Windows / 10,000 条 P95</a:t>
             </a:r>
           </a:p>
         </p:txBody>
@@ -13602,7 +13602,7 @@
                 </a:solidFill>
                 <a:latin typeface="Microsoft YaHei"/>
               </a:rPr>
-              <a:t>246.796 ms</a:t>
+              <a:t>67.320 ms</a:t>
             </a:r>
           </a:p>
         </p:txBody>
@@ -13637,7 +13637,7 @@
                 </a:solidFill>
                 <a:latin typeface="Microsoft YaHei"/>
               </a:rPr>
-              <a:t>Windows / HashEmbedding</a:t>
+              <a:t>80 个不同请求 / 实际服务</a:t>
             </a:r>
           </a:p>
         </p:txBody>
@@ -13726,7 +13726,7 @@
                 </a:solidFill>
                 <a:latin typeface="Microsoft YaHei"/>
               </a:rPr>
-              <a:t>第三轮10,000条热p99</a:t>
+              <a:t>麒麟 V11 / 10,000 条 P95</a:t>
             </a:r>
           </a:p>
         </p:txBody>
@@ -13761,7 +13761,7 @@
                 </a:solidFill>
                 <a:latin typeface="Microsoft YaHei"/>
               </a:rPr>
-              <a:t>362.265 ms</a:t>
+              <a:t>111.626 ms</a:t>
             </a:r>
           </a:p>
         </p:txBody>
@@ -13796,7 +13796,7 @@
                 </a:solidFill>
                 <a:latin typeface="Microsoft YaHei"/>
               </a:rPr>
-              <a:t>历史内部结果；官方使用P95</a:t>
+              <a:t>VMware / HashEmbedding</a:t>
             </a:r>
           </a:p>
         </p:txBody>
@@ -13885,7 +13885,7 @@
                 </a:solidFill>
                 <a:latin typeface="Microsoft YaHei"/>
               </a:rPr>
-              <a:t>SQLite 体积</a:t>
+              <a:t>固定配置</a:t>
             </a:r>
           </a:p>
         </p:txBody>
@@ -13920,7 +13920,7 @@
                 </a:solidFill>
                 <a:latin typeface="Microsoft YaHei"/>
               </a:rPr>
-              <a:t>39.984 MB</a:t>
+              <a:t>256 维 / top 3</a:t>
             </a:r>
           </a:p>
         </p:txBody>
@@ -13955,7 +13955,7 @@
                 </a:solidFill>
                 <a:latin typeface="Microsoft YaHei"/>
               </a:rPr>
-              <a:t>含缓存向量</a:t>
+              <a:t>阈值 0.265 / 不预热</a:t>
             </a:r>
           </a:p>
         </p:txBody>
@@ -13990,7 +13990,7 @@
                 </a:solidFill>
                 <a:latin typeface="Microsoft YaHei"/>
               </a:rPr>
-              <a:t>注意：开发机回退模型证据，不替代真实银河麒麟 SDK 性能验收</a:t>
+              <a:t>进程内 MemoryService.search，非 HTTP / Agent 推理；不是原生 SDK 性能</a:t>
             </a:r>
           </a:p>
         </p:txBody>

</xml_diff>

<commit_message>
test(release): seal verified Windows and V11 delivery evidence (R08)
</commit_message>
<xml_diff>
--- a/deliverables/ppt/OS_Agent_记忆优化_答辩稿.pptx
+++ b/deliverables/ppt/OS_Agent_记忆优化_答辩稿.pptx
@@ -4606,7 +4606,7 @@
                 </a:solidFill>
                 <a:latin typeface="Microsoft YaHei"/>
               </a:rPr>
-              <a:t>67.320 ms</a:t>
+              <a:t>77.629 ms</a:t>
             </a:r>
           </a:p>
         </p:txBody>
@@ -5109,7 +5109,7 @@
                 </a:solidFill>
                 <a:latin typeface="Microsoft YaHei"/>
               </a:rPr>
-              <a:t>146</a:t>
+              <a:t>164</a:t>
             </a:r>
           </a:p>
         </p:txBody>
@@ -5268,7 +5268,7 @@
                 </a:solidFill>
                 <a:latin typeface="Microsoft YaHei"/>
               </a:rPr>
-              <a:t>134</a:t>
+              <a:t>164</a:t>
             </a:r>
           </a:p>
         </p:txBody>
@@ -6661,7 +6661,7 @@
                 </a:solidFill>
                 <a:latin typeface="Microsoft YaHei"/>
               </a:rPr>
-              <a:t>五项逐请求、146 测试、V11 报告</a:t>
+              <a:t>五项逐请求、164 测试、V11 报告</a:t>
             </a:r>
           </a:p>
         </p:txBody>
@@ -8013,7 +8013,7 @@
                 </a:solidFill>
                 <a:latin typeface="Microsoft YaHei"/>
               </a:rPr>
-              <a:t>候选合并 + 向量缓存；V11 P95 111.626ms（Hash）</a:t>
+              <a:t>候选合并 + 向量缓存；V11 P95 156.977ms（Hash）</a:t>
             </a:r>
           </a:p>
         </p:txBody>
@@ -13602,7 +13602,7 @@
                 </a:solidFill>
                 <a:latin typeface="Microsoft YaHei"/>
               </a:rPr>
-              <a:t>67.320 ms</a:t>
+              <a:t>77.629 ms</a:t>
             </a:r>
           </a:p>
         </p:txBody>
@@ -13761,7 +13761,7 @@
                 </a:solidFill>
                 <a:latin typeface="Microsoft YaHei"/>
               </a:rPr>
-              <a:t>111.626 ms</a:t>
+              <a:t>156.977 ms</a:t>
             </a:r>
           </a:p>
         </p:txBody>

</xml_diff>